<commit_message>
Updating Advanced Components slide deck to fix typo
</commit_message>
<xml_diff>
--- a/slide_decks/React/React_Component_Advanced.pptx
+++ b/slide_decks/React/React_Component_Advanced.pptx
@@ -320,7 +320,7 @@
           </a:lstStyle>
           <a:p>
             <a:fld id="{CA869C63-99CE-7C40-A7E9-3930C61B23AB}" type="datetimeFigureOut">
-              <a:t>8/14/2026</a:t>
+              <a:t>8/21/2026</a:t>
             </a:fld>
             <a:endParaRPr lang="en-US" dirty="0"/>
           </a:p>
@@ -485,7 +485,7 @@
           <a:p>
             <a:fld id="{E3E59D94-626A-4CE8-9932-5221A04BF234}" type="datetimeFigureOut">
               <a:rPr lang="en-US" smtClean="0"/>
-              <a:t>8/14/2026</a:t>
+              <a:t>8/21/2026</a:t>
             </a:fld>
             <a:endParaRPr lang="en-US" dirty="0"/>
           </a:p>
@@ -43581,7 +43581,7 @@
         </p:spPr>
         <p:txBody>
           <a:bodyPr>
-            <a:normAutofit fontScale="92500" lnSpcReduction="20000"/>
+            <a:normAutofit fontScale="85000" lnSpcReduction="10000"/>
           </a:bodyPr>
           <a:lstStyle/>
           <a:p>
@@ -43607,16 +43607,12 @@
               <a:rPr lang="en-US" b="1" i="1" dirty="0"/>
               <a:t>ref</a:t>
             </a:r>
-            <a:endParaRPr lang="en-US" dirty="0"/>
           </a:p>
           <a:p>
-            <a:r>
-              <a:rPr lang="en-US" b="1" i="1" dirty="0"/>
-              <a:t>Refs</a:t>
-            </a:r>
+            <a:pPr lvl="1"/>
             <a:r>
               <a:rPr lang="en-US" dirty="0"/>
-              <a:t> (</a:t>
+              <a:t>Declare a Referenced variable using </a:t>
             </a:r>
             <a:r>
               <a:rPr lang="en-US" dirty="0" err="1">
@@ -43632,9 +43628,12 @@
               </a:rPr>
               <a:t> from ‘react’</a:t>
             </a:r>
+            <a:endParaRPr lang="en-US" dirty="0"/>
+          </a:p>
+          <a:p>
             <a:r>
               <a:rPr lang="en-US" dirty="0"/>
-              <a:t>) provide a way to directly reference a DOM element, letting you read it’s current value on demand.</a:t>
+              <a:t>The ref provides a way to directly reference a DOM element, letting you read it’s current value on demand.</a:t>
             </a:r>
           </a:p>
           <a:p>
@@ -43647,7 +43646,15 @@
           <a:p>
             <a:r>
               <a:rPr lang="en-US" dirty="0"/>
-              <a:t>Using a controlled component, there is not value prop tied to state, instead you attach a ref to the element via the ref attribute, and read the value as needed, such as on form submission/button press</a:t>
+              <a:t>Using </a:t>
+            </a:r>
+            <a:r>
+              <a:rPr lang="en-US"/>
+              <a:t>an uncontrolled </a:t>
+            </a:r>
+            <a:r>
+              <a:rPr lang="en-US" dirty="0"/>
+              <a:t>component, there is not value prop tied to state, instead you attach a ref to the element via the ref attribute, and read the value as needed, such as on form submission/button press</a:t>
             </a:r>
           </a:p>
           <a:p>
@@ -43804,33 +43811,15 @@
                                   </p:childTnLst>
                                 </p:cTn>
                               </p:par>
-                            </p:childTnLst>
-                          </p:cTn>
-                        </p:par>
-                      </p:childTnLst>
-                    </p:cTn>
-                  </p:par>
-                  <p:par>
-                    <p:cTn id="11" fill="hold">
-                      <p:stCondLst>
-                        <p:cond delay="indefinite"/>
-                      </p:stCondLst>
-                      <p:childTnLst>
-                        <p:par>
-                          <p:cTn id="12" fill="hold">
-                            <p:stCondLst>
-                              <p:cond delay="0"/>
-                            </p:stCondLst>
-                            <p:childTnLst>
                               <p:par>
-                                <p:cTn id="13" presetID="1" presetClass="entr" presetSubtype="0" fill="hold" grpId="0" nodeType="clickEffect">
+                                <p:cTn id="11" presetID="1" presetClass="entr" presetSubtype="0" fill="hold" grpId="0" nodeType="withEffect">
                                   <p:stCondLst>
                                     <p:cond delay="0"/>
                                   </p:stCondLst>
                                   <p:childTnLst>
                                     <p:set>
                                       <p:cBhvr>
-                                        <p:cTn id="14" dur="1" fill="hold">
+                                        <p:cTn id="12" dur="1" fill="hold">
                                           <p:stCondLst>
                                             <p:cond delay="0"/>
                                           </p:stCondLst>
@@ -43853,8 +43842,26 @@
                                   </p:childTnLst>
                                 </p:cTn>
                               </p:par>
+                            </p:childTnLst>
+                          </p:cTn>
+                        </p:par>
+                      </p:childTnLst>
+                    </p:cTn>
+                  </p:par>
+                  <p:par>
+                    <p:cTn id="13" fill="hold">
+                      <p:stCondLst>
+                        <p:cond delay="indefinite"/>
+                      </p:stCondLst>
+                      <p:childTnLst>
+                        <p:par>
+                          <p:cTn id="14" fill="hold">
+                            <p:stCondLst>
+                              <p:cond delay="0"/>
+                            </p:stCondLst>
+                            <p:childTnLst>
                               <p:par>
-                                <p:cTn id="15" presetID="1" presetClass="entr" presetSubtype="0" fill="hold" grpId="0" nodeType="withEffect">
+                                <p:cTn id="15" presetID="1" presetClass="entr" presetSubtype="0" fill="hold" grpId="0" nodeType="clickEffect">
                                   <p:stCondLst>
                                     <p:cond delay="0"/>
                                   </p:stCondLst>
@@ -43884,33 +43891,15 @@
                                   </p:childTnLst>
                                 </p:cTn>
                               </p:par>
-                            </p:childTnLst>
-                          </p:cTn>
-                        </p:par>
-                      </p:childTnLst>
-                    </p:cTn>
-                  </p:par>
-                  <p:par>
-                    <p:cTn id="17" fill="hold">
-                      <p:stCondLst>
-                        <p:cond delay="indefinite"/>
-                      </p:stCondLst>
-                      <p:childTnLst>
-                        <p:par>
-                          <p:cTn id="18" fill="hold">
-                            <p:stCondLst>
-                              <p:cond delay="0"/>
-                            </p:stCondLst>
-                            <p:childTnLst>
                               <p:par>
-                                <p:cTn id="19" presetID="1" presetClass="entr" presetSubtype="0" fill="hold" grpId="0" nodeType="clickEffect">
+                                <p:cTn id="17" presetID="1" presetClass="entr" presetSubtype="0" fill="hold" grpId="0" nodeType="withEffect">
                                   <p:stCondLst>
                                     <p:cond delay="0"/>
                                   </p:stCondLst>
                                   <p:childTnLst>
                                     <p:set>
                                       <p:cBhvr>
-                                        <p:cTn id="20" dur="1" fill="hold">
+                                        <p:cTn id="18" dur="1" fill="hold">
                                           <p:stCondLst>
                                             <p:cond delay="0"/>
                                           </p:stCondLst>
@@ -43933,8 +43922,26 @@
                                   </p:childTnLst>
                                 </p:cTn>
                               </p:par>
+                            </p:childTnLst>
+                          </p:cTn>
+                        </p:par>
+                      </p:childTnLst>
+                    </p:cTn>
+                  </p:par>
+                  <p:par>
+                    <p:cTn id="19" fill="hold">
+                      <p:stCondLst>
+                        <p:cond delay="indefinite"/>
+                      </p:stCondLst>
+                      <p:childTnLst>
+                        <p:par>
+                          <p:cTn id="20" fill="hold">
+                            <p:stCondLst>
+                              <p:cond delay="0"/>
+                            </p:stCondLst>
+                            <p:childTnLst>
                               <p:par>
-                                <p:cTn id="21" presetID="1" presetClass="entr" presetSubtype="0" fill="hold" grpId="0" nodeType="withEffect">
+                                <p:cTn id="21" presetID="1" presetClass="entr" presetSubtype="0" fill="hold" grpId="0" nodeType="clickEffect">
                                   <p:stCondLst>
                                     <p:cond delay="0"/>
                                   </p:stCondLst>
@@ -43950,6 +43957,37 @@
                                           <p:spTgt spid="6">
                                             <p:txEl>
                                               <p:pRg st="5" end="5"/>
+                                            </p:txEl>
+                                          </p:spTgt>
+                                        </p:tgtEl>
+                                        <p:attrNameLst>
+                                          <p:attrName>style.visibility</p:attrName>
+                                        </p:attrNameLst>
+                                      </p:cBhvr>
+                                      <p:to>
+                                        <p:strVal val="visible"/>
+                                      </p:to>
+                                    </p:set>
+                                  </p:childTnLst>
+                                </p:cTn>
+                              </p:par>
+                              <p:par>
+                                <p:cTn id="23" presetID="1" presetClass="entr" presetSubtype="0" fill="hold" grpId="0" nodeType="withEffect">
+                                  <p:stCondLst>
+                                    <p:cond delay="0"/>
+                                  </p:stCondLst>
+                                  <p:childTnLst>
+                                    <p:set>
+                                      <p:cBhvr>
+                                        <p:cTn id="24" dur="1" fill="hold">
+                                          <p:stCondLst>
+                                            <p:cond delay="0"/>
+                                          </p:stCondLst>
+                                        </p:cTn>
+                                        <p:tgtEl>
+                                          <p:spTgt spid="6">
+                                            <p:txEl>
+                                              <p:pRg st="6" end="6"/>
                                             </p:txEl>
                                           </p:spTgt>
                                         </p:tgtEl>
@@ -44083,7 +44121,7 @@
         </p:spPr>
         <p:txBody>
           <a:bodyPr>
-            <a:normAutofit fontScale="92500"/>
+            <a:normAutofit fontScale="92500" lnSpcReduction="10000"/>
           </a:bodyPr>
           <a:lstStyle/>
           <a:p>
@@ -44102,7 +44140,7 @@
             <a:pPr lvl="1"/>
             <a:r>
               <a:rPr lang="en-US" dirty="0"/>
-              <a:t>Simple forms when real-time reactivity isn’t needed</a:t>
+              <a:t>Simple forms when real-time reactivity isn’t needed (i.e. if you want active form validation – use a controlled component instead)</a:t>
             </a:r>
           </a:p>
           <a:p>

</xml_diff>